<commit_message>
Fix num_pages whitespace bug
</commit_message>
<xml_diff>
--- a/Presentation.pptx
+++ b/Presentation.pptx
@@ -10,6 +10,7 @@
     <p:sldId id="259" r:id="rId4"/>
     <p:sldId id="260" r:id="rId5"/>
     <p:sldId id="261" r:id="rId6"/>
+    <p:sldId id="262" r:id="rId7"/>
   </p:sldIdLst>
   <p:sldSz cx="12192000" cy="6858000"/>
   <p:notesSz cx="6858000" cy="9144000"/>
@@ -4495,13 +4496,8 @@
             </a:pPr>
             <a:r>
               <a:rPr lang="en-US" dirty="0"/>
-              <a:t>GET </a:t>
-            </a:r>
-            <a:r>
-              <a:rPr lang="en-US"/>
-              <a:t>/analytics/</a:t>
-            </a:r>
-            <a:endParaRPr lang="en-US" dirty="0"/>
+              <a:t>GET /analytics/</a:t>
+            </a:r>
           </a:p>
         </p:txBody>
       </p:sp>
@@ -4509,6 +4505,139 @@
     <p:extLst>
       <p:ext uri="{BB962C8B-B14F-4D97-AF65-F5344CB8AC3E}">
         <p14:creationId xmlns:p14="http://schemas.microsoft.com/office/powerpoint/2010/main" val="3574002379"/>
+      </p:ext>
+    </p:extLst>
+  </p:cSld>
+  <p:clrMapOvr>
+    <a:masterClrMapping/>
+  </p:clrMapOvr>
+</p:sld>
+</file>
+
+<file path=ppt/slides/slide6.xml><?xml version="1.0" encoding="utf-8"?>
+<p:sld xmlns:a="http://schemas.openxmlformats.org/drawingml/2006/main" xmlns:r="http://schemas.openxmlformats.org/officeDocument/2006/relationships" xmlns:p="http://schemas.openxmlformats.org/presentationml/2006/main">
+  <p:cSld>
+    <p:spTree>
+      <p:nvGrpSpPr>
+        <p:cNvPr id="1" name="">
+          <a:extLst>
+            <a:ext uri="{FF2B5EF4-FFF2-40B4-BE49-F238E27FC236}">
+              <a16:creationId xmlns:a16="http://schemas.microsoft.com/office/drawing/2014/main" id="{91D4B14A-3294-E865-C21E-FBA7025594E9}"/>
+            </a:ext>
+          </a:extLst>
+        </p:cNvPr>
+        <p:cNvGrpSpPr/>
+        <p:nvPr/>
+      </p:nvGrpSpPr>
+      <p:grpSpPr>
+        <a:xfrm>
+          <a:off x="0" y="0"/>
+          <a:ext cx="0" cy="0"/>
+          <a:chOff x="0" y="0"/>
+          <a:chExt cx="0" cy="0"/>
+        </a:xfrm>
+      </p:grpSpPr>
+      <p:sp>
+        <p:nvSpPr>
+          <p:cNvPr id="2" name="Title 1">
+            <a:extLst>
+              <a:ext uri="{FF2B5EF4-FFF2-40B4-BE49-F238E27FC236}">
+                <a16:creationId xmlns:a16="http://schemas.microsoft.com/office/drawing/2014/main" id="{5EF1E1E3-2369-5C0C-2DD4-C4F50E6A77BA}"/>
+              </a:ext>
+            </a:extLst>
+          </p:cNvPr>
+          <p:cNvSpPr>
+            <a:spLocks noGrp="1"/>
+          </p:cNvSpPr>
+          <p:nvPr>
+            <p:ph type="title"/>
+          </p:nvPr>
+        </p:nvSpPr>
+        <p:spPr>
+          <a:xfrm>
+            <a:off x="1371600" y="685800"/>
+            <a:ext cx="9601200" cy="896257"/>
+          </a:xfrm>
+        </p:spPr>
+        <p:txBody>
+          <a:bodyPr>
+            <a:normAutofit/>
+          </a:bodyPr>
+          <a:lstStyle/>
+          <a:p>
+            <a:r>
+              <a:rPr lang="en-US" dirty="0"/>
+              <a:t>Version Control</a:t>
+            </a:r>
+          </a:p>
+        </p:txBody>
+      </p:sp>
+      <p:sp>
+        <p:nvSpPr>
+          <p:cNvPr id="3" name="Content Placeholder 2">
+            <a:extLst>
+              <a:ext uri="{FF2B5EF4-FFF2-40B4-BE49-F238E27FC236}">
+                <a16:creationId xmlns:a16="http://schemas.microsoft.com/office/drawing/2014/main" id="{FFCC49FB-41FF-8D38-4209-997A65286D8D}"/>
+              </a:ext>
+            </a:extLst>
+          </p:cNvPr>
+          <p:cNvSpPr>
+            <a:spLocks noGrp="1"/>
+          </p:cNvSpPr>
+          <p:nvPr>
+            <p:ph idx="1"/>
+          </p:nvPr>
+        </p:nvSpPr>
+        <p:spPr>
+          <a:xfrm>
+            <a:off x="1371600" y="1582057"/>
+            <a:ext cx="9601200" cy="4285343"/>
+          </a:xfrm>
+        </p:spPr>
+        <p:txBody>
+          <a:bodyPr/>
+          <a:lstStyle/>
+          <a:p>
+            <a:r>
+              <a:rPr lang="en-US" dirty="0"/>
+              <a:t>Throughout the project I used Git to incrementally commit changes, usually after every feature or fix. This way, each commit represents a unit of work, and it is easy to roll back to a previous working version to find a bug if the app stops working.</a:t>
+            </a:r>
+          </a:p>
+          <a:p>
+            <a:r>
+              <a:rPr lang="en-US" dirty="0"/>
+              <a:t>A git ignore file is used to remove any files that should not be committed such as .env files and .db files. </a:t>
+            </a:r>
+          </a:p>
+          <a:p>
+            <a:r>
+              <a:rPr lang="en-US" dirty="0"/>
+              <a:t>Database files are not committed for the purpose of keeping the repository lightweight. Since it is already easy to set up the app, it does not add much complexity to generate the database from the dataset on set up.</a:t>
+            </a:r>
+          </a:p>
+          <a:p>
+            <a:r>
+              <a:rPr lang="en-US" dirty="0"/>
+              <a:t>To imitate team environments, branches were used for distinct features.</a:t>
+            </a:r>
+          </a:p>
+          <a:p>
+            <a:r>
+              <a:rPr lang="en-US" dirty="0"/>
+              <a:t>One limitation would be that code reviews were not performed before each push or merge, which is a common practice </a:t>
+            </a:r>
+            <a:r>
+              <a:rPr lang="en-US"/>
+              <a:t>in team-based development.</a:t>
+            </a:r>
+            <a:endParaRPr lang="en-US" dirty="0"/>
+          </a:p>
+        </p:txBody>
+      </p:sp>
+    </p:spTree>
+    <p:extLst>
+      <p:ext uri="{BB962C8B-B14F-4D97-AF65-F5344CB8AC3E}">
+        <p14:creationId xmlns:p14="http://schemas.microsoft.com/office/powerpoint/2010/main" val="2249047937"/>
       </p:ext>
     </p:extLst>
   </p:cSld>

</xml_diff>